<commit_message>
Category- Working with category
</commit_message>
<xml_diff>
--- a/.lessons/56 Category, Subcategory and Child Category Setup/1 Category- Working with category/1.pptx
+++ b/.lessons/56 Category, Subcategory and Child Category Setup/1 Category- Working with category/1.pptx
@@ -5,9 +5,24 @@
     <p:sldMasterId id="2147483648" r:id="rId1"/>
   </p:sldMasterIdLst>
   <p:sldIdLst>
-    <p:sldId id="413" r:id="rId2"/>
-    <p:sldId id="414" r:id="rId3"/>
-    <p:sldId id="400" r:id="rId4"/>
+    <p:sldId id="416" r:id="rId2"/>
+    <p:sldId id="413" r:id="rId3"/>
+    <p:sldId id="414" r:id="rId4"/>
+    <p:sldId id="415" r:id="rId5"/>
+    <p:sldId id="418" r:id="rId6"/>
+    <p:sldId id="419" r:id="rId7"/>
+    <p:sldId id="420" r:id="rId8"/>
+    <p:sldId id="421" r:id="rId9"/>
+    <p:sldId id="422" r:id="rId10"/>
+    <p:sldId id="423" r:id="rId11"/>
+    <p:sldId id="424" r:id="rId12"/>
+    <p:sldId id="417" r:id="rId13"/>
+    <p:sldId id="425" r:id="rId14"/>
+    <p:sldId id="426" r:id="rId15"/>
+    <p:sldId id="400" r:id="rId16"/>
+    <p:sldId id="427" r:id="rId17"/>
+    <p:sldId id="428" r:id="rId18"/>
+    <p:sldId id="429" r:id="rId19"/>
   </p:sldIdLst>
   <p:sldSz cx="12192000" cy="6858000"/>
   <p:notesSz cx="6858000" cy="9144000"/>
@@ -261,7 +276,7 @@
           <a:p>
             <a:fld id="{3E102D2E-813C-461C-9963-687A650C48C0}" type="datetimeFigureOut">
               <a:rPr lang="en-US" smtClean="0"/>
-              <a:t>6/26/2025</a:t>
+              <a:t>8/10/2025</a:t>
             </a:fld>
             <a:endParaRPr lang="en-US"/>
           </a:p>
@@ -459,7 +474,7 @@
           <a:p>
             <a:fld id="{3E102D2E-813C-461C-9963-687A650C48C0}" type="datetimeFigureOut">
               <a:rPr lang="en-US" smtClean="0"/>
-              <a:t>6/26/2025</a:t>
+              <a:t>8/10/2025</a:t>
             </a:fld>
             <a:endParaRPr lang="en-US"/>
           </a:p>
@@ -667,7 +682,7 @@
           <a:p>
             <a:fld id="{3E102D2E-813C-461C-9963-687A650C48C0}" type="datetimeFigureOut">
               <a:rPr lang="en-US" smtClean="0"/>
-              <a:t>6/26/2025</a:t>
+              <a:t>8/10/2025</a:t>
             </a:fld>
             <a:endParaRPr lang="en-US"/>
           </a:p>
@@ -865,7 +880,7 @@
           <a:p>
             <a:fld id="{3E102D2E-813C-461C-9963-687A650C48C0}" type="datetimeFigureOut">
               <a:rPr lang="en-US" smtClean="0"/>
-              <a:t>6/26/2025</a:t>
+              <a:t>8/10/2025</a:t>
             </a:fld>
             <a:endParaRPr lang="en-US"/>
           </a:p>
@@ -1140,7 +1155,7 @@
           <a:p>
             <a:fld id="{3E102D2E-813C-461C-9963-687A650C48C0}" type="datetimeFigureOut">
               <a:rPr lang="en-US" smtClean="0"/>
-              <a:t>6/26/2025</a:t>
+              <a:t>8/10/2025</a:t>
             </a:fld>
             <a:endParaRPr lang="en-US"/>
           </a:p>
@@ -1405,7 +1420,7 @@
           <a:p>
             <a:fld id="{3E102D2E-813C-461C-9963-687A650C48C0}" type="datetimeFigureOut">
               <a:rPr lang="en-US" smtClean="0"/>
-              <a:t>6/26/2025</a:t>
+              <a:t>8/10/2025</a:t>
             </a:fld>
             <a:endParaRPr lang="en-US"/>
           </a:p>
@@ -1817,7 +1832,7 @@
           <a:p>
             <a:fld id="{3E102D2E-813C-461C-9963-687A650C48C0}" type="datetimeFigureOut">
               <a:rPr lang="en-US" smtClean="0"/>
-              <a:t>6/26/2025</a:t>
+              <a:t>8/10/2025</a:t>
             </a:fld>
             <a:endParaRPr lang="en-US"/>
           </a:p>
@@ -1958,7 +1973,7 @@
           <a:p>
             <a:fld id="{3E102D2E-813C-461C-9963-687A650C48C0}" type="datetimeFigureOut">
               <a:rPr lang="en-US" smtClean="0"/>
-              <a:t>6/26/2025</a:t>
+              <a:t>8/10/2025</a:t>
             </a:fld>
             <a:endParaRPr lang="en-US"/>
           </a:p>
@@ -2071,7 +2086,7 @@
           <a:p>
             <a:fld id="{3E102D2E-813C-461C-9963-687A650C48C0}" type="datetimeFigureOut">
               <a:rPr lang="en-US" smtClean="0"/>
-              <a:t>6/26/2025</a:t>
+              <a:t>8/10/2025</a:t>
             </a:fld>
             <a:endParaRPr lang="en-US"/>
           </a:p>
@@ -2382,7 +2397,7 @@
           <a:p>
             <a:fld id="{3E102D2E-813C-461C-9963-687A650C48C0}" type="datetimeFigureOut">
               <a:rPr lang="en-US" smtClean="0"/>
-              <a:t>6/26/2025</a:t>
+              <a:t>8/10/2025</a:t>
             </a:fld>
             <a:endParaRPr lang="en-US"/>
           </a:p>
@@ -2670,7 +2685,7 @@
           <a:p>
             <a:fld id="{3E102D2E-813C-461C-9963-687A650C48C0}" type="datetimeFigureOut">
               <a:rPr lang="en-US" smtClean="0"/>
-              <a:t>6/26/2025</a:t>
+              <a:t>8/10/2025</a:t>
             </a:fld>
             <a:endParaRPr lang="en-US"/>
           </a:p>
@@ -2911,7 +2926,7 @@
           <a:p>
             <a:fld id="{3E102D2E-813C-461C-9963-687A650C48C0}" type="datetimeFigureOut">
               <a:rPr lang="en-US" smtClean="0"/>
-              <a:t>6/26/2025</a:t>
+              <a:t>8/10/2025</a:t>
             </a:fld>
             <a:endParaRPr lang="en-US"/>
           </a:p>
@@ -3319,6 +3334,1256 @@
         <p:cNvPr id="1" name="">
           <a:extLst>
             <a:ext uri="{FF2B5EF4-FFF2-40B4-BE49-F238E27FC236}">
+              <a16:creationId xmlns:a16="http://schemas.microsoft.com/office/drawing/2014/main" id="{FD8C3626-5BED-5790-4FA7-AC474459A15F}"/>
+            </a:ext>
+          </a:extLst>
+        </p:cNvPr>
+        <p:cNvGrpSpPr/>
+        <p:nvPr/>
+      </p:nvGrpSpPr>
+      <p:grpSpPr>
+        <a:xfrm>
+          <a:off x="0" y="0"/>
+          <a:ext cx="0" cy="0"/>
+          <a:chOff x="0" y="0"/>
+          <a:chExt cx="0" cy="0"/>
+        </a:xfrm>
+      </p:grpSpPr>
+      <p:sp>
+        <p:nvSpPr>
+          <p:cNvPr id="3" name="TextBox 2">
+            <a:extLst>
+              <a:ext uri="{FF2B5EF4-FFF2-40B4-BE49-F238E27FC236}">
+                <a16:creationId xmlns:a16="http://schemas.microsoft.com/office/drawing/2014/main" id="{FA536871-A18E-C0A7-90F2-7D5686A18C99}"/>
+              </a:ext>
+            </a:extLst>
+          </p:cNvPr>
+          <p:cNvSpPr txBox="1"/>
+          <p:nvPr/>
+        </p:nvSpPr>
+        <p:spPr>
+          <a:xfrm>
+            <a:off x="217714" y="255046"/>
+            <a:ext cx="11756571" cy="955518"/>
+          </a:xfrm>
+          <a:prstGeom prst="rect">
+            <a:avLst/>
+          </a:prstGeom>
+          <a:noFill/>
+        </p:spPr>
+        <p:txBody>
+          <a:bodyPr wrap="square">
+            <a:spAutoFit/>
+          </a:bodyPr>
+          <a:lstStyle/>
+          <a:p>
+            <a:pPr>
+              <a:lnSpc>
+                <a:spcPct val="150000"/>
+              </a:lnSpc>
+              <a:buNone/>
+            </a:pPr>
+            <a:r>
+              <a:rPr kumimoji="0" lang="az-Latn-AZ" altLang="en-US" sz="1300" b="0" i="0" u="none" strike="noStrike" cap="none" normalizeH="0" baseline="0">
+                <a:ln>
+                  <a:noFill/>
+                </a:ln>
+                <a:solidFill>
+                  <a:schemeClr val="tx1"/>
+                </a:solidFill>
+                <a:effectLst/>
+                <a:latin typeface="Arial" panose="020B0604020202020204" pitchFamily="34" charset="0"/>
+              </a:rPr>
+              <a:t>Bu dərsdə kateqoriyalar necə yaradılır haqqında öyrənəcəyik.</a:t>
+            </a:r>
+          </a:p>
+          <a:p>
+            <a:pPr>
+              <a:lnSpc>
+                <a:spcPct val="150000"/>
+              </a:lnSpc>
+              <a:buNone/>
+            </a:pPr>
+            <a:endParaRPr lang="az-Latn-AZ" altLang="en-US" sz="1300">
+              <a:latin typeface="Arial" panose="020B0604020202020204" pitchFamily="34" charset="0"/>
+            </a:endParaRPr>
+          </a:p>
+          <a:p>
+            <a:pPr>
+              <a:lnSpc>
+                <a:spcPct val="150000"/>
+              </a:lnSpc>
+              <a:buNone/>
+            </a:pPr>
+            <a:r>
+              <a:rPr kumimoji="0" lang="az-Latn-AZ" altLang="en-US" sz="1300" b="0" i="0" u="none" strike="noStrike" cap="none" normalizeH="0" baseline="0">
+                <a:ln>
+                  <a:noFill/>
+                </a:ln>
+                <a:solidFill>
+                  <a:schemeClr val="tx1"/>
+                </a:solidFill>
+                <a:effectLst/>
+                <a:latin typeface="Arial" panose="020B0604020202020204" pitchFamily="34" charset="0"/>
+              </a:rPr>
+              <a:t>İlk olaraq isə </a:t>
+            </a:r>
+            <a:r>
+              <a:rPr kumimoji="0" lang="az-Latn-AZ" altLang="en-US" sz="1300" b="1" i="0" u="none" strike="noStrike" cap="none" normalizeH="0" baseline="0">
+                <a:ln>
+                  <a:noFill/>
+                </a:ln>
+                <a:solidFill>
+                  <a:schemeClr val="tx1"/>
+                </a:solidFill>
+                <a:effectLst/>
+                <a:latin typeface="Arial" panose="020B0604020202020204" pitchFamily="34" charset="0"/>
+              </a:rPr>
+              <a:t>Dashboard</a:t>
+            </a:r>
+            <a:r>
+              <a:rPr kumimoji="0" lang="az-Latn-AZ" altLang="en-US" sz="1300" b="0" i="0" u="none" strike="noStrike" cap="none" normalizeH="0" baseline="0">
+                <a:ln>
+                  <a:noFill/>
+                </a:ln>
+                <a:solidFill>
+                  <a:schemeClr val="tx1"/>
+                </a:solidFill>
+                <a:effectLst/>
+                <a:latin typeface="Arial" panose="020B0604020202020204" pitchFamily="34" charset="0"/>
+              </a:rPr>
+              <a:t> səhifəsinə keçid linkini redakde edək.</a:t>
+            </a:r>
+            <a:endParaRPr kumimoji="0" lang="en-US" altLang="en-US" sz="1300" b="0" i="0" u="none" strike="noStrike" cap="none" normalizeH="0" baseline="0">
+              <a:ln>
+                <a:noFill/>
+              </a:ln>
+              <a:solidFill>
+                <a:schemeClr val="tx1"/>
+              </a:solidFill>
+              <a:effectLst/>
+              <a:latin typeface="Arial" panose="020B0604020202020204" pitchFamily="34" charset="0"/>
+            </a:endParaRPr>
+          </a:p>
+        </p:txBody>
+      </p:sp>
+    </p:spTree>
+    <p:extLst>
+      <p:ext uri="{BB962C8B-B14F-4D97-AF65-F5344CB8AC3E}">
+        <p14:creationId xmlns:p14="http://schemas.microsoft.com/office/powerpoint/2010/main" val="1586432410"/>
+      </p:ext>
+    </p:extLst>
+  </p:cSld>
+  <p:clrMapOvr>
+    <a:masterClrMapping/>
+  </p:clrMapOvr>
+</p:sld>
+</file>
+
+<file path=ppt/slides/slide10.xml><?xml version="1.0" encoding="utf-8"?>
+<p:sld xmlns:a="http://schemas.openxmlformats.org/drawingml/2006/main" xmlns:r="http://schemas.openxmlformats.org/officeDocument/2006/relationships" xmlns:p="http://schemas.openxmlformats.org/presentationml/2006/main">
+  <p:cSld>
+    <p:spTree>
+      <p:nvGrpSpPr>
+        <p:cNvPr id="1" name="">
+          <a:extLst>
+            <a:ext uri="{FF2B5EF4-FFF2-40B4-BE49-F238E27FC236}">
+              <a16:creationId xmlns:a16="http://schemas.microsoft.com/office/drawing/2014/main" id="{FF5265A1-C3CB-2547-D0FF-71E098F75A94}"/>
+            </a:ext>
+          </a:extLst>
+        </p:cNvPr>
+        <p:cNvGrpSpPr/>
+        <p:nvPr/>
+      </p:nvGrpSpPr>
+      <p:grpSpPr>
+        <a:xfrm>
+          <a:off x="0" y="0"/>
+          <a:ext cx="0" cy="0"/>
+          <a:chOff x="0" y="0"/>
+          <a:chExt cx="0" cy="0"/>
+        </a:xfrm>
+      </p:grpSpPr>
+      <p:sp>
+        <p:nvSpPr>
+          <p:cNvPr id="3" name="TextBox 2">
+            <a:extLst>
+              <a:ext uri="{FF2B5EF4-FFF2-40B4-BE49-F238E27FC236}">
+                <a16:creationId xmlns:a16="http://schemas.microsoft.com/office/drawing/2014/main" id="{0087E1BF-C175-3C44-405C-F681B6E4979E}"/>
+              </a:ext>
+            </a:extLst>
+          </p:cNvPr>
+          <p:cNvSpPr txBox="1"/>
+          <p:nvPr/>
+        </p:nvSpPr>
+        <p:spPr>
+          <a:xfrm>
+            <a:off x="217713" y="101411"/>
+            <a:ext cx="11756571" cy="355354"/>
+          </a:xfrm>
+          <a:prstGeom prst="rect">
+            <a:avLst/>
+          </a:prstGeom>
+          <a:noFill/>
+        </p:spPr>
+        <p:txBody>
+          <a:bodyPr wrap="square">
+            <a:spAutoFit/>
+          </a:bodyPr>
+          <a:lstStyle/>
+          <a:p>
+            <a:pPr>
+              <a:lnSpc>
+                <a:spcPct val="150000"/>
+              </a:lnSpc>
+              <a:buNone/>
+            </a:pPr>
+            <a:r>
+              <a:rPr lang="az-Latn-AZ" altLang="en-US" sz="1300">
+                <a:latin typeface="Arial" panose="020B0604020202020204" pitchFamily="34" charset="0"/>
+              </a:rPr>
+              <a:t>Kateqoriya əlavə etmək, update etmək və görüntüləmək üçün istifadə ediləcək şablonlarımızı yaradırıq.</a:t>
+            </a:r>
+            <a:endParaRPr kumimoji="0" lang="en-US" altLang="en-US" sz="1300" b="0" i="0" u="none" strike="noStrike" cap="none" normalizeH="0" baseline="0">
+              <a:ln>
+                <a:noFill/>
+              </a:ln>
+              <a:solidFill>
+                <a:schemeClr val="tx1"/>
+              </a:solidFill>
+              <a:effectLst/>
+              <a:latin typeface="Arial" panose="020B0604020202020204" pitchFamily="34" charset="0"/>
+            </a:endParaRPr>
+          </a:p>
+        </p:txBody>
+      </p:sp>
+      <p:pic>
+        <p:nvPicPr>
+          <p:cNvPr id="4" name="Picture 3">
+            <a:extLst>
+              <a:ext uri="{FF2B5EF4-FFF2-40B4-BE49-F238E27FC236}">
+                <a16:creationId xmlns:a16="http://schemas.microsoft.com/office/drawing/2014/main" id="{F7A9920F-2D85-F46B-9A3B-829E087AE298}"/>
+              </a:ext>
+            </a:extLst>
+          </p:cNvPr>
+          <p:cNvPicPr>
+            <a:picLocks noChangeAspect="1"/>
+          </p:cNvPicPr>
+          <p:nvPr/>
+        </p:nvPicPr>
+        <p:blipFill>
+          <a:blip r:embed="rId2"/>
+          <a:stretch>
+            <a:fillRect/>
+          </a:stretch>
+        </p:blipFill>
+        <p:spPr>
+          <a:xfrm>
+            <a:off x="-1" y="502945"/>
+            <a:ext cx="12192000" cy="6355055"/>
+          </a:xfrm>
+          <a:prstGeom prst="rect">
+            <a:avLst/>
+          </a:prstGeom>
+        </p:spPr>
+      </p:pic>
+    </p:spTree>
+    <p:extLst>
+      <p:ext uri="{BB962C8B-B14F-4D97-AF65-F5344CB8AC3E}">
+        <p14:creationId xmlns:p14="http://schemas.microsoft.com/office/powerpoint/2010/main" val="2751841912"/>
+      </p:ext>
+    </p:extLst>
+  </p:cSld>
+  <p:clrMapOvr>
+    <a:masterClrMapping/>
+  </p:clrMapOvr>
+</p:sld>
+</file>
+
+<file path=ppt/slides/slide11.xml><?xml version="1.0" encoding="utf-8"?>
+<p:sld xmlns:a="http://schemas.openxmlformats.org/drawingml/2006/main" xmlns:r="http://schemas.openxmlformats.org/officeDocument/2006/relationships" xmlns:p="http://schemas.openxmlformats.org/presentationml/2006/main">
+  <p:cSld>
+    <p:spTree>
+      <p:nvGrpSpPr>
+        <p:cNvPr id="1" name="">
+          <a:extLst>
+            <a:ext uri="{FF2B5EF4-FFF2-40B4-BE49-F238E27FC236}">
+              <a16:creationId xmlns:a16="http://schemas.microsoft.com/office/drawing/2014/main" id="{C1F2F379-5E89-050B-59B6-321ED9291C30}"/>
+            </a:ext>
+          </a:extLst>
+        </p:cNvPr>
+        <p:cNvGrpSpPr/>
+        <p:nvPr/>
+      </p:nvGrpSpPr>
+      <p:grpSpPr>
+        <a:xfrm>
+          <a:off x="0" y="0"/>
+          <a:ext cx="0" cy="0"/>
+          <a:chOff x="0" y="0"/>
+          <a:chExt cx="0" cy="0"/>
+        </a:xfrm>
+      </p:grpSpPr>
+      <p:sp>
+        <p:nvSpPr>
+          <p:cNvPr id="3" name="TextBox 2">
+            <a:extLst>
+              <a:ext uri="{FF2B5EF4-FFF2-40B4-BE49-F238E27FC236}">
+                <a16:creationId xmlns:a16="http://schemas.microsoft.com/office/drawing/2014/main" id="{B5667B44-6487-EA2A-6678-4E1FAD8C3033}"/>
+              </a:ext>
+            </a:extLst>
+          </p:cNvPr>
+          <p:cNvSpPr txBox="1"/>
+          <p:nvPr/>
+        </p:nvSpPr>
+        <p:spPr>
+          <a:xfrm>
+            <a:off x="217714" y="255046"/>
+            <a:ext cx="11756571" cy="355354"/>
+          </a:xfrm>
+          <a:prstGeom prst="rect">
+            <a:avLst/>
+          </a:prstGeom>
+          <a:noFill/>
+        </p:spPr>
+        <p:txBody>
+          <a:bodyPr wrap="square">
+            <a:spAutoFit/>
+          </a:bodyPr>
+          <a:lstStyle/>
+          <a:p>
+            <a:pPr>
+              <a:lnSpc>
+                <a:spcPct val="150000"/>
+              </a:lnSpc>
+              <a:buNone/>
+            </a:pPr>
+            <a:r>
+              <a:rPr lang="en-US" altLang="en-US" sz="1300">
+                <a:latin typeface="Arial" panose="020B0604020202020204" pitchFamily="34" charset="0"/>
+              </a:rPr>
+              <a:t>&lt;a&gt; </a:t>
+            </a:r>
+            <a:r>
+              <a:rPr lang="az-Latn-AZ" altLang="en-US" sz="1300">
+                <a:latin typeface="Arial" panose="020B0604020202020204" pitchFamily="34" charset="0"/>
+              </a:rPr>
+              <a:t>elementi əlavə edirik Kateqoriya şablonuna keçid etmək üçün.</a:t>
+            </a:r>
+            <a:endParaRPr kumimoji="0" lang="en-US" altLang="en-US" sz="1300" b="0" i="0" u="none" strike="noStrike" cap="none" normalizeH="0" baseline="0">
+              <a:ln>
+                <a:noFill/>
+              </a:ln>
+              <a:solidFill>
+                <a:schemeClr val="tx1"/>
+              </a:solidFill>
+              <a:effectLst/>
+              <a:latin typeface="Arial" panose="020B0604020202020204" pitchFamily="34" charset="0"/>
+            </a:endParaRPr>
+          </a:p>
+        </p:txBody>
+      </p:sp>
+      <p:pic>
+        <p:nvPicPr>
+          <p:cNvPr id="4" name="Picture 3">
+            <a:extLst>
+              <a:ext uri="{FF2B5EF4-FFF2-40B4-BE49-F238E27FC236}">
+                <a16:creationId xmlns:a16="http://schemas.microsoft.com/office/drawing/2014/main" id="{5887C7E5-A906-E743-7154-7F51B4602D6D}"/>
+              </a:ext>
+            </a:extLst>
+          </p:cNvPr>
+          <p:cNvPicPr>
+            <a:picLocks noChangeAspect="1"/>
+          </p:cNvPicPr>
+          <p:nvPr/>
+        </p:nvPicPr>
+        <p:blipFill>
+          <a:blip r:embed="rId2"/>
+          <a:stretch>
+            <a:fillRect/>
+          </a:stretch>
+        </p:blipFill>
+        <p:spPr>
+          <a:xfrm>
+            <a:off x="2992436" y="849744"/>
+            <a:ext cx="9199564" cy="6008255"/>
+          </a:xfrm>
+          <a:prstGeom prst="rect">
+            <a:avLst/>
+          </a:prstGeom>
+        </p:spPr>
+      </p:pic>
+    </p:spTree>
+    <p:extLst>
+      <p:ext uri="{BB962C8B-B14F-4D97-AF65-F5344CB8AC3E}">
+        <p14:creationId xmlns:p14="http://schemas.microsoft.com/office/powerpoint/2010/main" val="657990749"/>
+      </p:ext>
+    </p:extLst>
+  </p:cSld>
+  <p:clrMapOvr>
+    <a:masterClrMapping/>
+  </p:clrMapOvr>
+</p:sld>
+</file>
+
+<file path=ppt/slides/slide12.xml><?xml version="1.0" encoding="utf-8"?>
+<p:sld xmlns:a="http://schemas.openxmlformats.org/drawingml/2006/main" xmlns:r="http://schemas.openxmlformats.org/officeDocument/2006/relationships" xmlns:p="http://schemas.openxmlformats.org/presentationml/2006/main">
+  <p:cSld>
+    <p:spTree>
+      <p:nvGrpSpPr>
+        <p:cNvPr id="1" name="">
+          <a:extLst>
+            <a:ext uri="{FF2B5EF4-FFF2-40B4-BE49-F238E27FC236}">
+              <a16:creationId xmlns:a16="http://schemas.microsoft.com/office/drawing/2014/main" id="{F1106334-0647-1FD2-E6B6-445922AEF203}"/>
+            </a:ext>
+          </a:extLst>
+        </p:cNvPr>
+        <p:cNvGrpSpPr/>
+        <p:nvPr/>
+      </p:nvGrpSpPr>
+      <p:grpSpPr>
+        <a:xfrm>
+          <a:off x="0" y="0"/>
+          <a:ext cx="0" cy="0"/>
+          <a:chOff x="0" y="0"/>
+          <a:chExt cx="0" cy="0"/>
+        </a:xfrm>
+      </p:grpSpPr>
+      <p:sp>
+        <p:nvSpPr>
+          <p:cNvPr id="3" name="TextBox 2">
+            <a:extLst>
+              <a:ext uri="{FF2B5EF4-FFF2-40B4-BE49-F238E27FC236}">
+                <a16:creationId xmlns:a16="http://schemas.microsoft.com/office/drawing/2014/main" id="{0F13D9EC-078F-DE4F-FCF8-07CC7601E667}"/>
+              </a:ext>
+            </a:extLst>
+          </p:cNvPr>
+          <p:cNvSpPr txBox="1"/>
+          <p:nvPr/>
+        </p:nvSpPr>
+        <p:spPr>
+          <a:xfrm>
+            <a:off x="217715" y="255046"/>
+            <a:ext cx="5721268" cy="655436"/>
+          </a:xfrm>
+          <a:prstGeom prst="rect">
+            <a:avLst/>
+          </a:prstGeom>
+          <a:noFill/>
+        </p:spPr>
+        <p:txBody>
+          <a:bodyPr wrap="square">
+            <a:spAutoFit/>
+          </a:bodyPr>
+          <a:lstStyle/>
+          <a:p>
+            <a:pPr>
+              <a:lnSpc>
+                <a:spcPct val="150000"/>
+              </a:lnSpc>
+              <a:buNone/>
+            </a:pPr>
+            <a:r>
+              <a:rPr lang="az-Latn-AZ" altLang="en-US" sz="1300" b="1">
+                <a:latin typeface="Arial" panose="020B0604020202020204" pitchFamily="34" charset="0"/>
+              </a:rPr>
+              <a:t>CategoryController</a:t>
+            </a:r>
+            <a:r>
+              <a:rPr lang="az-Latn-AZ" altLang="en-US" sz="1300">
+                <a:latin typeface="Arial" panose="020B0604020202020204" pitchFamily="34" charset="0"/>
+              </a:rPr>
+              <a:t> də, </a:t>
+            </a:r>
+            <a:r>
+              <a:rPr lang="az-Latn-AZ" altLang="en-US" sz="1300" b="1">
+                <a:latin typeface="Arial" panose="020B0604020202020204" pitchFamily="34" charset="0"/>
+              </a:rPr>
+              <a:t>index() </a:t>
+            </a:r>
+            <a:r>
+              <a:rPr lang="az-Latn-AZ" altLang="en-US" sz="1300">
+                <a:latin typeface="Arial" panose="020B0604020202020204" pitchFamily="34" charset="0"/>
+              </a:rPr>
+              <a:t>metoduna yazırıq ki, hansı şablonu göstərsin.</a:t>
+            </a:r>
+            <a:endParaRPr kumimoji="0" lang="en-US" altLang="en-US" sz="1300" b="0" i="0" u="none" strike="noStrike" cap="none" normalizeH="0" baseline="0">
+              <a:ln>
+                <a:noFill/>
+              </a:ln>
+              <a:solidFill>
+                <a:schemeClr val="tx1"/>
+              </a:solidFill>
+              <a:effectLst/>
+              <a:latin typeface="Arial" panose="020B0604020202020204" pitchFamily="34" charset="0"/>
+            </a:endParaRPr>
+          </a:p>
+        </p:txBody>
+      </p:sp>
+      <p:pic>
+        <p:nvPicPr>
+          <p:cNvPr id="4" name="Picture 3">
+            <a:extLst>
+              <a:ext uri="{FF2B5EF4-FFF2-40B4-BE49-F238E27FC236}">
+                <a16:creationId xmlns:a16="http://schemas.microsoft.com/office/drawing/2014/main" id="{78C22D21-F674-FBCD-E1AC-B4E0554A2987}"/>
+              </a:ext>
+            </a:extLst>
+          </p:cNvPr>
+          <p:cNvPicPr>
+            <a:picLocks noChangeAspect="1"/>
+          </p:cNvPicPr>
+          <p:nvPr/>
+        </p:nvPicPr>
+        <p:blipFill>
+          <a:blip r:embed="rId2"/>
+          <a:stretch>
+            <a:fillRect/>
+          </a:stretch>
+        </p:blipFill>
+        <p:spPr>
+          <a:xfrm>
+            <a:off x="6048521" y="0"/>
+            <a:ext cx="6143479" cy="6858000"/>
+          </a:xfrm>
+          <a:prstGeom prst="rect">
+            <a:avLst/>
+          </a:prstGeom>
+        </p:spPr>
+      </p:pic>
+    </p:spTree>
+    <p:extLst>
+      <p:ext uri="{BB962C8B-B14F-4D97-AF65-F5344CB8AC3E}">
+        <p14:creationId xmlns:p14="http://schemas.microsoft.com/office/powerpoint/2010/main" val="3285348310"/>
+      </p:ext>
+    </p:extLst>
+  </p:cSld>
+  <p:clrMapOvr>
+    <a:masterClrMapping/>
+  </p:clrMapOvr>
+</p:sld>
+</file>
+
+<file path=ppt/slides/slide13.xml><?xml version="1.0" encoding="utf-8"?>
+<p:sld xmlns:a="http://schemas.openxmlformats.org/drawingml/2006/main" xmlns:r="http://schemas.openxmlformats.org/officeDocument/2006/relationships" xmlns:p="http://schemas.openxmlformats.org/presentationml/2006/main">
+  <p:cSld>
+    <p:spTree>
+      <p:nvGrpSpPr>
+        <p:cNvPr id="1" name="">
+          <a:extLst>
+            <a:ext uri="{FF2B5EF4-FFF2-40B4-BE49-F238E27FC236}">
+              <a16:creationId xmlns:a16="http://schemas.microsoft.com/office/drawing/2014/main" id="{F0CB9A55-3BC6-3344-0990-F4BF0E9782CA}"/>
+            </a:ext>
+          </a:extLst>
+        </p:cNvPr>
+        <p:cNvGrpSpPr/>
+        <p:nvPr/>
+      </p:nvGrpSpPr>
+      <p:grpSpPr>
+        <a:xfrm>
+          <a:off x="0" y="0"/>
+          <a:ext cx="0" cy="0"/>
+          <a:chOff x="0" y="0"/>
+          <a:chExt cx="0" cy="0"/>
+        </a:xfrm>
+      </p:grpSpPr>
+      <p:sp>
+        <p:nvSpPr>
+          <p:cNvPr id="3" name="TextBox 2">
+            <a:extLst>
+              <a:ext uri="{FF2B5EF4-FFF2-40B4-BE49-F238E27FC236}">
+                <a16:creationId xmlns:a16="http://schemas.microsoft.com/office/drawing/2014/main" id="{4204D27F-3418-3E4E-CE24-76FF0BCED048}"/>
+              </a:ext>
+            </a:extLst>
+          </p:cNvPr>
+          <p:cNvSpPr txBox="1"/>
+          <p:nvPr/>
+        </p:nvSpPr>
+        <p:spPr>
+          <a:xfrm>
+            <a:off x="217714" y="255046"/>
+            <a:ext cx="11756571" cy="355354"/>
+          </a:xfrm>
+          <a:prstGeom prst="rect">
+            <a:avLst/>
+          </a:prstGeom>
+          <a:noFill/>
+        </p:spPr>
+        <p:txBody>
+          <a:bodyPr wrap="square">
+            <a:spAutoFit/>
+          </a:bodyPr>
+          <a:lstStyle/>
+          <a:p>
+            <a:pPr>
+              <a:lnSpc>
+                <a:spcPct val="150000"/>
+              </a:lnSpc>
+              <a:buNone/>
+            </a:pPr>
+            <a:r>
+              <a:rPr lang="az-Latn-AZ" altLang="en-US" sz="1300">
+                <a:latin typeface="Arial" panose="020B0604020202020204" pitchFamily="34" charset="0"/>
+              </a:rPr>
+              <a:t>Hazırki nəticə.</a:t>
+            </a:r>
+            <a:endParaRPr kumimoji="0" lang="en-US" altLang="en-US" sz="1300" b="0" i="0" u="none" strike="noStrike" cap="none" normalizeH="0" baseline="0">
+              <a:ln>
+                <a:noFill/>
+              </a:ln>
+              <a:solidFill>
+                <a:schemeClr val="tx1"/>
+              </a:solidFill>
+              <a:effectLst/>
+              <a:latin typeface="Arial" panose="020B0604020202020204" pitchFamily="34" charset="0"/>
+            </a:endParaRPr>
+          </a:p>
+        </p:txBody>
+      </p:sp>
+      <p:pic>
+        <p:nvPicPr>
+          <p:cNvPr id="4" name="Picture 3">
+            <a:extLst>
+              <a:ext uri="{FF2B5EF4-FFF2-40B4-BE49-F238E27FC236}">
+                <a16:creationId xmlns:a16="http://schemas.microsoft.com/office/drawing/2014/main" id="{31F47E60-97BE-88D9-5682-5416B82D2735}"/>
+              </a:ext>
+            </a:extLst>
+          </p:cNvPr>
+          <p:cNvPicPr>
+            <a:picLocks noChangeAspect="1"/>
+          </p:cNvPicPr>
+          <p:nvPr/>
+        </p:nvPicPr>
+        <p:blipFill>
+          <a:blip r:embed="rId2"/>
+          <a:stretch>
+            <a:fillRect/>
+          </a:stretch>
+        </p:blipFill>
+        <p:spPr>
+          <a:xfrm>
+            <a:off x="-1" y="3948184"/>
+            <a:ext cx="12192000" cy="2909816"/>
+          </a:xfrm>
+          <a:prstGeom prst="rect">
+            <a:avLst/>
+          </a:prstGeom>
+          <a:ln w="38100" cap="sq">
+            <a:solidFill>
+              <a:srgbClr val="000000"/>
+            </a:solidFill>
+            <a:prstDash val="solid"/>
+            <a:miter lim="800000"/>
+          </a:ln>
+          <a:effectLst>
+            <a:outerShdw blurRad="50800" dist="38100" dir="2700000" algn="tl" rotWithShape="0">
+              <a:srgbClr val="000000">
+                <a:alpha val="43000"/>
+              </a:srgbClr>
+            </a:outerShdw>
+          </a:effectLst>
+        </p:spPr>
+      </p:pic>
+    </p:spTree>
+    <p:extLst>
+      <p:ext uri="{BB962C8B-B14F-4D97-AF65-F5344CB8AC3E}">
+        <p14:creationId xmlns:p14="http://schemas.microsoft.com/office/powerpoint/2010/main" val="940373864"/>
+      </p:ext>
+    </p:extLst>
+  </p:cSld>
+  <p:clrMapOvr>
+    <a:masterClrMapping/>
+  </p:clrMapOvr>
+</p:sld>
+</file>
+
+<file path=ppt/slides/slide14.xml><?xml version="1.0" encoding="utf-8"?>
+<p:sld xmlns:a="http://schemas.openxmlformats.org/drawingml/2006/main" xmlns:r="http://schemas.openxmlformats.org/officeDocument/2006/relationships" xmlns:p="http://schemas.openxmlformats.org/presentationml/2006/main">
+  <p:cSld>
+    <p:spTree>
+      <p:nvGrpSpPr>
+        <p:cNvPr id="1" name="">
+          <a:extLst>
+            <a:ext uri="{FF2B5EF4-FFF2-40B4-BE49-F238E27FC236}">
+              <a16:creationId xmlns:a16="http://schemas.microsoft.com/office/drawing/2014/main" id="{F5DD578A-50D8-0E83-D2F1-5AF727B8AAB7}"/>
+            </a:ext>
+          </a:extLst>
+        </p:cNvPr>
+        <p:cNvGrpSpPr/>
+        <p:nvPr/>
+      </p:nvGrpSpPr>
+      <p:grpSpPr>
+        <a:xfrm>
+          <a:off x="0" y="0"/>
+          <a:ext cx="0" cy="0"/>
+          <a:chOff x="0" y="0"/>
+          <a:chExt cx="0" cy="0"/>
+        </a:xfrm>
+      </p:grpSpPr>
+      <p:sp>
+        <p:nvSpPr>
+          <p:cNvPr id="3" name="TextBox 2">
+            <a:extLst>
+              <a:ext uri="{FF2B5EF4-FFF2-40B4-BE49-F238E27FC236}">
+                <a16:creationId xmlns:a16="http://schemas.microsoft.com/office/drawing/2014/main" id="{9E235EDB-3D19-0215-CB7A-FED0C1481213}"/>
+              </a:ext>
+            </a:extLst>
+          </p:cNvPr>
+          <p:cNvSpPr txBox="1"/>
+          <p:nvPr/>
+        </p:nvSpPr>
+        <p:spPr>
+          <a:xfrm>
+            <a:off x="217714" y="55417"/>
+            <a:ext cx="11756571" cy="355354"/>
+          </a:xfrm>
+          <a:prstGeom prst="rect">
+            <a:avLst/>
+          </a:prstGeom>
+          <a:noFill/>
+        </p:spPr>
+        <p:txBody>
+          <a:bodyPr wrap="square">
+            <a:spAutoFit/>
+          </a:bodyPr>
+          <a:lstStyle/>
+          <a:p>
+            <a:pPr>
+              <a:lnSpc>
+                <a:spcPct val="150000"/>
+              </a:lnSpc>
+              <a:buNone/>
+            </a:pPr>
+            <a:r>
+              <a:rPr kumimoji="0" lang="az-Latn-AZ" altLang="en-US" sz="1300" b="1" i="0" u="none" strike="noStrike" cap="none" normalizeH="0" baseline="0">
+                <a:ln>
+                  <a:noFill/>
+                </a:ln>
+                <a:solidFill>
+                  <a:schemeClr val="tx1"/>
+                </a:solidFill>
+                <a:effectLst/>
+                <a:latin typeface="Arial" panose="020B0604020202020204" pitchFamily="34" charset="0"/>
+              </a:rPr>
+              <a:t>slider</a:t>
+            </a:r>
+            <a:r>
+              <a:rPr kumimoji="0" lang="en-US" altLang="en-US" sz="1300" b="1" i="0" u="none" strike="noStrike" cap="none" normalizeH="0" baseline="0">
+                <a:ln>
+                  <a:noFill/>
+                </a:ln>
+                <a:solidFill>
+                  <a:schemeClr val="tx1"/>
+                </a:solidFill>
+                <a:effectLst/>
+                <a:latin typeface="Arial" panose="020B0604020202020204" pitchFamily="34" charset="0"/>
+              </a:rPr>
+              <a:t>/index.blade.php </a:t>
+            </a:r>
+            <a:r>
+              <a:rPr kumimoji="0" lang="az-Latn-AZ" altLang="en-US" sz="1300" b="0" i="0" u="none" strike="noStrike" cap="none" normalizeH="0" baseline="0">
+                <a:ln>
+                  <a:noFill/>
+                </a:ln>
+                <a:solidFill>
+                  <a:schemeClr val="tx1"/>
+                </a:solidFill>
+                <a:effectLst/>
+                <a:latin typeface="Arial" panose="020B0604020202020204" pitchFamily="34" charset="0"/>
+              </a:rPr>
+              <a:t>faylını kopyalayırıq </a:t>
+            </a:r>
+            <a:r>
+              <a:rPr kumimoji="0" lang="az-Latn-AZ" altLang="en-US" sz="1300" b="1" i="0" u="none" strike="noStrike" cap="none" normalizeH="0" baseline="0">
+                <a:ln>
+                  <a:noFill/>
+                </a:ln>
+                <a:solidFill>
+                  <a:schemeClr val="tx1"/>
+                </a:solidFill>
+                <a:effectLst/>
+                <a:latin typeface="Arial" panose="020B0604020202020204" pitchFamily="34" charset="0"/>
+              </a:rPr>
+              <a:t>category</a:t>
+            </a:r>
+            <a:r>
+              <a:rPr kumimoji="0" lang="en-US" altLang="en-US" sz="1300" b="1" i="0" u="none" strike="noStrike" cap="none" normalizeH="0" baseline="0">
+                <a:ln>
+                  <a:noFill/>
+                </a:ln>
+                <a:solidFill>
+                  <a:schemeClr val="tx1"/>
+                </a:solidFill>
+                <a:effectLst/>
+                <a:latin typeface="Arial" panose="020B0604020202020204" pitchFamily="34" charset="0"/>
+              </a:rPr>
+              <a:t>/index.blade.php </a:t>
+            </a:r>
+            <a:r>
+              <a:rPr kumimoji="0" lang="az-Latn-AZ" altLang="en-US" sz="1300" b="0" i="0" u="none" strike="noStrike" cap="none" normalizeH="0" baseline="0">
+                <a:ln>
+                  <a:noFill/>
+                </a:ln>
+                <a:solidFill>
+                  <a:schemeClr val="tx1"/>
+                </a:solidFill>
+                <a:effectLst/>
+                <a:latin typeface="Arial" panose="020B0604020202020204" pitchFamily="34" charset="0"/>
+              </a:rPr>
+              <a:t>faylına və hələlik bir-iki hissədə dəyişiklik edirik.</a:t>
+            </a:r>
+            <a:endParaRPr kumimoji="0" lang="en-US" altLang="en-US" sz="1300" b="0" i="0" u="none" strike="noStrike" cap="none" normalizeH="0" baseline="0">
+              <a:ln>
+                <a:noFill/>
+              </a:ln>
+              <a:solidFill>
+                <a:schemeClr val="tx1"/>
+              </a:solidFill>
+              <a:effectLst/>
+              <a:latin typeface="Arial" panose="020B0604020202020204" pitchFamily="34" charset="0"/>
+            </a:endParaRPr>
+          </a:p>
+        </p:txBody>
+      </p:sp>
+      <p:pic>
+        <p:nvPicPr>
+          <p:cNvPr id="4" name="Picture 3">
+            <a:extLst>
+              <a:ext uri="{FF2B5EF4-FFF2-40B4-BE49-F238E27FC236}">
+                <a16:creationId xmlns:a16="http://schemas.microsoft.com/office/drawing/2014/main" id="{59A9F3E4-6331-1638-8BD2-0D5D25467FA9}"/>
+              </a:ext>
+            </a:extLst>
+          </p:cNvPr>
+          <p:cNvPicPr>
+            <a:picLocks noChangeAspect="1"/>
+          </p:cNvPicPr>
+          <p:nvPr/>
+        </p:nvPicPr>
+        <p:blipFill>
+          <a:blip r:embed="rId2"/>
+          <a:stretch>
+            <a:fillRect/>
+          </a:stretch>
+        </p:blipFill>
+        <p:spPr>
+          <a:xfrm>
+            <a:off x="0" y="482247"/>
+            <a:ext cx="12192000" cy="6375753"/>
+          </a:xfrm>
+          <a:prstGeom prst="rect">
+            <a:avLst/>
+          </a:prstGeom>
+        </p:spPr>
+      </p:pic>
+    </p:spTree>
+    <p:extLst>
+      <p:ext uri="{BB962C8B-B14F-4D97-AF65-F5344CB8AC3E}">
+        <p14:creationId xmlns:p14="http://schemas.microsoft.com/office/powerpoint/2010/main" val="2071599912"/>
+      </p:ext>
+    </p:extLst>
+  </p:cSld>
+  <p:clrMapOvr>
+    <a:masterClrMapping/>
+  </p:clrMapOvr>
+</p:sld>
+</file>
+
+<file path=ppt/slides/slide15.xml><?xml version="1.0" encoding="utf-8"?>
+<p:sld xmlns:a="http://schemas.openxmlformats.org/drawingml/2006/main" xmlns:r="http://schemas.openxmlformats.org/officeDocument/2006/relationships" xmlns:p="http://schemas.openxmlformats.org/presentationml/2006/main">
+  <p:cSld>
+    <p:spTree>
+      <p:nvGrpSpPr>
+        <p:cNvPr id="1" name="">
+          <a:extLst>
+            <a:ext uri="{FF2B5EF4-FFF2-40B4-BE49-F238E27FC236}">
+              <a16:creationId xmlns:a16="http://schemas.microsoft.com/office/drawing/2014/main" id="{ECE25D7D-A080-F22B-7E8D-36EC827289A1}"/>
+            </a:ext>
+          </a:extLst>
+        </p:cNvPr>
+        <p:cNvGrpSpPr/>
+        <p:nvPr/>
+      </p:nvGrpSpPr>
+      <p:grpSpPr>
+        <a:xfrm>
+          <a:off x="0" y="0"/>
+          <a:ext cx="0" cy="0"/>
+          <a:chOff x="0" y="0"/>
+          <a:chExt cx="0" cy="0"/>
+        </a:xfrm>
+      </p:grpSpPr>
+      <p:sp>
+        <p:nvSpPr>
+          <p:cNvPr id="3" name="TextBox 2">
+            <a:extLst>
+              <a:ext uri="{FF2B5EF4-FFF2-40B4-BE49-F238E27FC236}">
+                <a16:creationId xmlns:a16="http://schemas.microsoft.com/office/drawing/2014/main" id="{E33F16A3-A6E8-401E-847B-09570DC6E4CB}"/>
+              </a:ext>
+            </a:extLst>
+          </p:cNvPr>
+          <p:cNvSpPr txBox="1"/>
+          <p:nvPr/>
+        </p:nvSpPr>
+        <p:spPr>
+          <a:xfrm>
+            <a:off x="217714" y="255046"/>
+            <a:ext cx="11756571" cy="355354"/>
+          </a:xfrm>
+          <a:prstGeom prst="rect">
+            <a:avLst/>
+          </a:prstGeom>
+          <a:noFill/>
+        </p:spPr>
+        <p:txBody>
+          <a:bodyPr wrap="square">
+            <a:spAutoFit/>
+          </a:bodyPr>
+          <a:lstStyle/>
+          <a:p>
+            <a:pPr>
+              <a:lnSpc>
+                <a:spcPct val="150000"/>
+              </a:lnSpc>
+              <a:buNone/>
+            </a:pPr>
+            <a:r>
+              <a:rPr lang="az-Latn-AZ" altLang="en-US" sz="1300">
+                <a:latin typeface="Arial" panose="020B0604020202020204" pitchFamily="34" charset="0"/>
+              </a:rPr>
+              <a:t>Son nəticə.</a:t>
+            </a:r>
+            <a:endParaRPr kumimoji="0" lang="en-US" altLang="en-US" sz="1300" b="0" i="0" u="none" strike="noStrike" cap="none" normalizeH="0" baseline="0">
+              <a:ln>
+                <a:noFill/>
+              </a:ln>
+              <a:solidFill>
+                <a:schemeClr val="tx1"/>
+              </a:solidFill>
+              <a:effectLst/>
+              <a:latin typeface="Arial" panose="020B0604020202020204" pitchFamily="34" charset="0"/>
+            </a:endParaRPr>
+          </a:p>
+        </p:txBody>
+      </p:sp>
+      <p:pic>
+        <p:nvPicPr>
+          <p:cNvPr id="4" name="Picture 3">
+            <a:extLst>
+              <a:ext uri="{FF2B5EF4-FFF2-40B4-BE49-F238E27FC236}">
+                <a16:creationId xmlns:a16="http://schemas.microsoft.com/office/drawing/2014/main" id="{13DD7AC6-45C5-CA11-F822-AD178D632699}"/>
+              </a:ext>
+            </a:extLst>
+          </p:cNvPr>
+          <p:cNvPicPr>
+            <a:picLocks noChangeAspect="1"/>
+          </p:cNvPicPr>
+          <p:nvPr/>
+        </p:nvPicPr>
+        <p:blipFill>
+          <a:blip r:embed="rId2"/>
+          <a:stretch>
+            <a:fillRect/>
+          </a:stretch>
+        </p:blipFill>
+        <p:spPr>
+          <a:xfrm>
+            <a:off x="0" y="3020601"/>
+            <a:ext cx="12192000" cy="3837399"/>
+          </a:xfrm>
+          <a:prstGeom prst="rect">
+            <a:avLst/>
+          </a:prstGeom>
+          <a:ln w="38100" cap="sq">
+            <a:solidFill>
+              <a:srgbClr val="000000"/>
+            </a:solidFill>
+            <a:prstDash val="solid"/>
+            <a:miter lim="800000"/>
+          </a:ln>
+          <a:effectLst>
+            <a:outerShdw blurRad="50800" dist="38100" dir="2700000" algn="tl" rotWithShape="0">
+              <a:srgbClr val="000000">
+                <a:alpha val="43000"/>
+              </a:srgbClr>
+            </a:outerShdw>
+          </a:effectLst>
+        </p:spPr>
+      </p:pic>
+    </p:spTree>
+    <p:extLst>
+      <p:ext uri="{BB962C8B-B14F-4D97-AF65-F5344CB8AC3E}">
+        <p14:creationId xmlns:p14="http://schemas.microsoft.com/office/powerpoint/2010/main" val="3095838342"/>
+      </p:ext>
+    </p:extLst>
+  </p:cSld>
+  <p:clrMapOvr>
+    <a:masterClrMapping/>
+  </p:clrMapOvr>
+</p:sld>
+</file>
+
+<file path=ppt/slides/slide16.xml><?xml version="1.0" encoding="utf-8"?>
+<p:sld xmlns:a="http://schemas.openxmlformats.org/drawingml/2006/main" xmlns:r="http://schemas.openxmlformats.org/officeDocument/2006/relationships" xmlns:p="http://schemas.openxmlformats.org/presentationml/2006/main">
+  <p:cSld>
+    <p:spTree>
+      <p:nvGrpSpPr>
+        <p:cNvPr id="1" name="">
+          <a:extLst>
+            <a:ext uri="{FF2B5EF4-FFF2-40B4-BE49-F238E27FC236}">
+              <a16:creationId xmlns:a16="http://schemas.microsoft.com/office/drawing/2014/main" id="{0F1677A0-C57A-F150-9227-860591EF3E0A}"/>
+            </a:ext>
+          </a:extLst>
+        </p:cNvPr>
+        <p:cNvGrpSpPr/>
+        <p:nvPr/>
+      </p:nvGrpSpPr>
+      <p:grpSpPr>
+        <a:xfrm>
+          <a:off x="0" y="0"/>
+          <a:ext cx="0" cy="0"/>
+          <a:chOff x="0" y="0"/>
+          <a:chExt cx="0" cy="0"/>
+        </a:xfrm>
+      </p:grpSpPr>
+      <p:sp>
+        <p:nvSpPr>
+          <p:cNvPr id="3" name="TextBox 2">
+            <a:extLst>
+              <a:ext uri="{FF2B5EF4-FFF2-40B4-BE49-F238E27FC236}">
+                <a16:creationId xmlns:a16="http://schemas.microsoft.com/office/drawing/2014/main" id="{4F97EE90-81DA-E5D5-9C38-0AD7FA781627}"/>
+              </a:ext>
+            </a:extLst>
+          </p:cNvPr>
+          <p:cNvSpPr txBox="1"/>
+          <p:nvPr/>
+        </p:nvSpPr>
+        <p:spPr>
+          <a:xfrm>
+            <a:off x="217714" y="255046"/>
+            <a:ext cx="11756571" cy="355354"/>
+          </a:xfrm>
+          <a:prstGeom prst="rect">
+            <a:avLst/>
+          </a:prstGeom>
+          <a:noFill/>
+        </p:spPr>
+        <p:txBody>
+          <a:bodyPr wrap="square">
+            <a:spAutoFit/>
+          </a:bodyPr>
+          <a:lstStyle/>
+          <a:p>
+            <a:pPr>
+              <a:lnSpc>
+                <a:spcPct val="150000"/>
+              </a:lnSpc>
+              <a:buNone/>
+            </a:pPr>
+            <a:r>
+              <a:rPr kumimoji="0" lang="en-US" altLang="en-US" sz="1300" b="0" i="0" u="none" strike="noStrike" cap="none" normalizeH="0" baseline="0">
+                <a:ln>
+                  <a:noFill/>
+                </a:ln>
+                <a:solidFill>
+                  <a:schemeClr val="tx1"/>
+                </a:solidFill>
+                <a:effectLst/>
+                <a:latin typeface="Arial" panose="020B0604020202020204" pitchFamily="34" charset="0"/>
+              </a:rPr>
+              <a:t>.</a:t>
+            </a:r>
+          </a:p>
+        </p:txBody>
+      </p:sp>
+    </p:spTree>
+    <p:extLst>
+      <p:ext uri="{BB962C8B-B14F-4D97-AF65-F5344CB8AC3E}">
+        <p14:creationId xmlns:p14="http://schemas.microsoft.com/office/powerpoint/2010/main" val="3833149275"/>
+      </p:ext>
+    </p:extLst>
+  </p:cSld>
+  <p:clrMapOvr>
+    <a:masterClrMapping/>
+  </p:clrMapOvr>
+</p:sld>
+</file>
+
+<file path=ppt/slides/slide17.xml><?xml version="1.0" encoding="utf-8"?>
+<p:sld xmlns:a="http://schemas.openxmlformats.org/drawingml/2006/main" xmlns:r="http://schemas.openxmlformats.org/officeDocument/2006/relationships" xmlns:p="http://schemas.openxmlformats.org/presentationml/2006/main">
+  <p:cSld>
+    <p:spTree>
+      <p:nvGrpSpPr>
+        <p:cNvPr id="1" name="">
+          <a:extLst>
+            <a:ext uri="{FF2B5EF4-FFF2-40B4-BE49-F238E27FC236}">
+              <a16:creationId xmlns:a16="http://schemas.microsoft.com/office/drawing/2014/main" id="{DE3A84C9-CA10-46B8-7E43-A0216F10D807}"/>
+            </a:ext>
+          </a:extLst>
+        </p:cNvPr>
+        <p:cNvGrpSpPr/>
+        <p:nvPr/>
+      </p:nvGrpSpPr>
+      <p:grpSpPr>
+        <a:xfrm>
+          <a:off x="0" y="0"/>
+          <a:ext cx="0" cy="0"/>
+          <a:chOff x="0" y="0"/>
+          <a:chExt cx="0" cy="0"/>
+        </a:xfrm>
+      </p:grpSpPr>
+      <p:sp>
+        <p:nvSpPr>
+          <p:cNvPr id="3" name="TextBox 2">
+            <a:extLst>
+              <a:ext uri="{FF2B5EF4-FFF2-40B4-BE49-F238E27FC236}">
+                <a16:creationId xmlns:a16="http://schemas.microsoft.com/office/drawing/2014/main" id="{0EE8B820-2613-97CE-151D-51AFDA6697F4}"/>
+              </a:ext>
+            </a:extLst>
+          </p:cNvPr>
+          <p:cNvSpPr txBox="1"/>
+          <p:nvPr/>
+        </p:nvSpPr>
+        <p:spPr>
+          <a:xfrm>
+            <a:off x="217714" y="255046"/>
+            <a:ext cx="11756571" cy="355354"/>
+          </a:xfrm>
+          <a:prstGeom prst="rect">
+            <a:avLst/>
+          </a:prstGeom>
+          <a:noFill/>
+        </p:spPr>
+        <p:txBody>
+          <a:bodyPr wrap="square">
+            <a:spAutoFit/>
+          </a:bodyPr>
+          <a:lstStyle/>
+          <a:p>
+            <a:pPr>
+              <a:lnSpc>
+                <a:spcPct val="150000"/>
+              </a:lnSpc>
+              <a:buNone/>
+            </a:pPr>
+            <a:r>
+              <a:rPr kumimoji="0" lang="en-US" altLang="en-US" sz="1300" b="0" i="0" u="none" strike="noStrike" cap="none" normalizeH="0" baseline="0">
+                <a:ln>
+                  <a:noFill/>
+                </a:ln>
+                <a:solidFill>
+                  <a:schemeClr val="tx1"/>
+                </a:solidFill>
+                <a:effectLst/>
+                <a:latin typeface="Arial" panose="020B0604020202020204" pitchFamily="34" charset="0"/>
+              </a:rPr>
+              <a:t>.</a:t>
+            </a:r>
+          </a:p>
+        </p:txBody>
+      </p:sp>
+    </p:spTree>
+    <p:extLst>
+      <p:ext uri="{BB962C8B-B14F-4D97-AF65-F5344CB8AC3E}">
+        <p14:creationId xmlns:p14="http://schemas.microsoft.com/office/powerpoint/2010/main" val="3876396410"/>
+      </p:ext>
+    </p:extLst>
+  </p:cSld>
+  <p:clrMapOvr>
+    <a:masterClrMapping/>
+  </p:clrMapOvr>
+</p:sld>
+</file>
+
+<file path=ppt/slides/slide18.xml><?xml version="1.0" encoding="utf-8"?>
+<p:sld xmlns:a="http://schemas.openxmlformats.org/drawingml/2006/main" xmlns:r="http://schemas.openxmlformats.org/officeDocument/2006/relationships" xmlns:p="http://schemas.openxmlformats.org/presentationml/2006/main">
+  <p:cSld>
+    <p:spTree>
+      <p:nvGrpSpPr>
+        <p:cNvPr id="1" name="">
+          <a:extLst>
+            <a:ext uri="{FF2B5EF4-FFF2-40B4-BE49-F238E27FC236}">
+              <a16:creationId xmlns:a16="http://schemas.microsoft.com/office/drawing/2014/main" id="{78F1550D-99B4-D65B-8340-BD64FF1F61F5}"/>
+            </a:ext>
+          </a:extLst>
+        </p:cNvPr>
+        <p:cNvGrpSpPr/>
+        <p:nvPr/>
+      </p:nvGrpSpPr>
+      <p:grpSpPr>
+        <a:xfrm>
+          <a:off x="0" y="0"/>
+          <a:ext cx="0" cy="0"/>
+          <a:chOff x="0" y="0"/>
+          <a:chExt cx="0" cy="0"/>
+        </a:xfrm>
+      </p:grpSpPr>
+      <p:sp>
+        <p:nvSpPr>
+          <p:cNvPr id="3" name="TextBox 2">
+            <a:extLst>
+              <a:ext uri="{FF2B5EF4-FFF2-40B4-BE49-F238E27FC236}">
+                <a16:creationId xmlns:a16="http://schemas.microsoft.com/office/drawing/2014/main" id="{CBCF2A40-A348-4BA5-5879-ED0EDF34E5C0}"/>
+              </a:ext>
+            </a:extLst>
+          </p:cNvPr>
+          <p:cNvSpPr txBox="1"/>
+          <p:nvPr/>
+        </p:nvSpPr>
+        <p:spPr>
+          <a:xfrm>
+            <a:off x="217714" y="255046"/>
+            <a:ext cx="11756571" cy="355354"/>
+          </a:xfrm>
+          <a:prstGeom prst="rect">
+            <a:avLst/>
+          </a:prstGeom>
+          <a:noFill/>
+        </p:spPr>
+        <p:txBody>
+          <a:bodyPr wrap="square">
+            <a:spAutoFit/>
+          </a:bodyPr>
+          <a:lstStyle/>
+          <a:p>
+            <a:pPr>
+              <a:lnSpc>
+                <a:spcPct val="150000"/>
+              </a:lnSpc>
+              <a:buNone/>
+            </a:pPr>
+            <a:r>
+              <a:rPr kumimoji="0" lang="en-US" altLang="en-US" sz="1300" b="0" i="0" u="none" strike="noStrike" cap="none" normalizeH="0" baseline="0">
+                <a:ln>
+                  <a:noFill/>
+                </a:ln>
+                <a:solidFill>
+                  <a:schemeClr val="tx1"/>
+                </a:solidFill>
+                <a:effectLst/>
+                <a:latin typeface="Arial" panose="020B0604020202020204" pitchFamily="34" charset="0"/>
+              </a:rPr>
+              <a:t>.</a:t>
+            </a:r>
+          </a:p>
+        </p:txBody>
+      </p:sp>
+    </p:spTree>
+    <p:extLst>
+      <p:ext uri="{BB962C8B-B14F-4D97-AF65-F5344CB8AC3E}">
+        <p14:creationId xmlns:p14="http://schemas.microsoft.com/office/powerpoint/2010/main" val="3578488883"/>
+      </p:ext>
+    </p:extLst>
+  </p:cSld>
+  <p:clrMapOvr>
+    <a:masterClrMapping/>
+  </p:clrMapOvr>
+</p:sld>
+</file>
+
+<file path=ppt/slides/slide2.xml><?xml version="1.0" encoding="utf-8"?>
+<p:sld xmlns:a="http://schemas.openxmlformats.org/drawingml/2006/main" xmlns:r="http://schemas.openxmlformats.org/officeDocument/2006/relationships" xmlns:p="http://schemas.openxmlformats.org/presentationml/2006/main">
+  <p:cSld>
+    <p:spTree>
+      <p:nvGrpSpPr>
+        <p:cNvPr id="1" name="">
+          <a:extLst>
+            <a:ext uri="{FF2B5EF4-FFF2-40B4-BE49-F238E27FC236}">
               <a16:creationId xmlns:a16="http://schemas.microsoft.com/office/drawing/2014/main" id="{6A435CBA-29A4-BFD2-CEA7-3290D85ED9F8}"/>
             </a:ext>
           </a:extLst>
@@ -3384,6 +4649,36 @@
           </a:p>
         </p:txBody>
       </p:sp>
+      <p:pic>
+        <p:nvPicPr>
+          <p:cNvPr id="4" name="Picture 3">
+            <a:extLst>
+              <a:ext uri="{FF2B5EF4-FFF2-40B4-BE49-F238E27FC236}">
+                <a16:creationId xmlns:a16="http://schemas.microsoft.com/office/drawing/2014/main" id="{9485B7D4-FEED-7662-D78A-920DE54357A5}"/>
+              </a:ext>
+            </a:extLst>
+          </p:cNvPr>
+          <p:cNvPicPr>
+            <a:picLocks noChangeAspect="1"/>
+          </p:cNvPicPr>
+          <p:nvPr/>
+        </p:nvPicPr>
+        <p:blipFill>
+          <a:blip r:embed="rId2"/>
+          <a:stretch>
+            <a:fillRect/>
+          </a:stretch>
+        </p:blipFill>
+        <p:spPr>
+          <a:xfrm>
+            <a:off x="2281382" y="818716"/>
+            <a:ext cx="9910617" cy="6039283"/>
+          </a:xfrm>
+          <a:prstGeom prst="rect">
+            <a:avLst/>
+          </a:prstGeom>
+        </p:spPr>
+      </p:pic>
     </p:spTree>
     <p:extLst>
       <p:ext uri="{BB962C8B-B14F-4D97-AF65-F5344CB8AC3E}">
@@ -3397,7 +4692,7 @@
 </p:sld>
 </file>
 
-<file path=ppt/slides/slide2.xml><?xml version="1.0" encoding="utf-8"?>
+<file path=ppt/slides/slide3.xml><?xml version="1.0" encoding="utf-8"?>
 <p:sld xmlns:a="http://schemas.openxmlformats.org/drawingml/2006/main" xmlns:r="http://schemas.openxmlformats.org/officeDocument/2006/relationships" xmlns:p="http://schemas.openxmlformats.org/presentationml/2006/main">
   <p:cSld>
     <p:spTree>
@@ -3470,6 +4765,36 @@
           </a:p>
         </p:txBody>
       </p:sp>
+      <p:pic>
+        <p:nvPicPr>
+          <p:cNvPr id="4" name="Picture 3">
+            <a:extLst>
+              <a:ext uri="{FF2B5EF4-FFF2-40B4-BE49-F238E27FC236}">
+                <a16:creationId xmlns:a16="http://schemas.microsoft.com/office/drawing/2014/main" id="{BAAE38E0-B03B-E0CD-5151-B2638DBBAD0E}"/>
+              </a:ext>
+            </a:extLst>
+          </p:cNvPr>
+          <p:cNvPicPr>
+            <a:picLocks noChangeAspect="1"/>
+          </p:cNvPicPr>
+          <p:nvPr/>
+        </p:nvPicPr>
+        <p:blipFill>
+          <a:blip r:embed="rId2"/>
+          <a:stretch>
+            <a:fillRect/>
+          </a:stretch>
+        </p:blipFill>
+        <p:spPr>
+          <a:xfrm>
+            <a:off x="0" y="1517904"/>
+            <a:ext cx="12192000" cy="5340096"/>
+          </a:xfrm>
+          <a:prstGeom prst="rect">
+            <a:avLst/>
+          </a:prstGeom>
+        </p:spPr>
+      </p:pic>
     </p:spTree>
     <p:extLst>
       <p:ext uri="{BB962C8B-B14F-4D97-AF65-F5344CB8AC3E}">
@@ -3483,7 +4808,7 @@
 </p:sld>
 </file>
 
-<file path=ppt/slides/slide3.xml><?xml version="1.0" encoding="utf-8"?>
+<file path=ppt/slides/slide4.xml><?xml version="1.0" encoding="utf-8"?>
 <p:sld xmlns:a="http://schemas.openxmlformats.org/drawingml/2006/main" xmlns:r="http://schemas.openxmlformats.org/officeDocument/2006/relationships" xmlns:p="http://schemas.openxmlformats.org/presentationml/2006/main">
   <p:cSld>
     <p:spTree>
@@ -3491,7 +4816,7 @@
         <p:cNvPr id="1" name="">
           <a:extLst>
             <a:ext uri="{FF2B5EF4-FFF2-40B4-BE49-F238E27FC236}">
-              <a16:creationId xmlns:a16="http://schemas.microsoft.com/office/drawing/2014/main" id="{ECE25D7D-A080-F22B-7E8D-36EC827289A1}"/>
+              <a16:creationId xmlns:a16="http://schemas.microsoft.com/office/drawing/2014/main" id="{D992500A-D7D5-90D2-A577-BB6E45F77748}"/>
             </a:ext>
           </a:extLst>
         </p:cNvPr>
@@ -3511,7 +4836,7 @@
           <p:cNvPr id="3" name="TextBox 2">
             <a:extLst>
               <a:ext uri="{FF2B5EF4-FFF2-40B4-BE49-F238E27FC236}">
-                <a16:creationId xmlns:a16="http://schemas.microsoft.com/office/drawing/2014/main" id="{E33F16A3-A6E8-401E-847B-09570DC6E4CB}"/>
+                <a16:creationId xmlns:a16="http://schemas.microsoft.com/office/drawing/2014/main" id="{50AA2D7B-BE5F-C1D7-BFCA-2F0869BE6C33}"/>
               </a:ext>
             </a:extLst>
           </p:cNvPr>
@@ -3556,10 +4881,707 @@
           </a:p>
         </p:txBody>
       </p:sp>
+      <p:pic>
+        <p:nvPicPr>
+          <p:cNvPr id="4" name="Picture 3">
+            <a:extLst>
+              <a:ext uri="{FF2B5EF4-FFF2-40B4-BE49-F238E27FC236}">
+                <a16:creationId xmlns:a16="http://schemas.microsoft.com/office/drawing/2014/main" id="{2166D00A-1D23-184D-88A2-9F961D4AF8E4}"/>
+              </a:ext>
+            </a:extLst>
+          </p:cNvPr>
+          <p:cNvPicPr>
+            <a:picLocks noChangeAspect="1"/>
+          </p:cNvPicPr>
+          <p:nvPr/>
+        </p:nvPicPr>
+        <p:blipFill>
+          <a:blip r:embed="rId2"/>
+          <a:stretch>
+            <a:fillRect/>
+          </a:stretch>
+        </p:blipFill>
+        <p:spPr>
+          <a:xfrm>
+            <a:off x="0" y="1203555"/>
+            <a:ext cx="12192000" cy="5654445"/>
+          </a:xfrm>
+          <a:prstGeom prst="rect">
+            <a:avLst/>
+          </a:prstGeom>
+        </p:spPr>
+      </p:pic>
     </p:spTree>
     <p:extLst>
       <p:ext uri="{BB962C8B-B14F-4D97-AF65-F5344CB8AC3E}">
-        <p14:creationId xmlns:p14="http://schemas.microsoft.com/office/powerpoint/2010/main" val="3095838342"/>
+        <p14:creationId xmlns:p14="http://schemas.microsoft.com/office/powerpoint/2010/main" val="3049040122"/>
+      </p:ext>
+    </p:extLst>
+  </p:cSld>
+  <p:clrMapOvr>
+    <a:masterClrMapping/>
+  </p:clrMapOvr>
+</p:sld>
+</file>
+
+<file path=ppt/slides/slide5.xml><?xml version="1.0" encoding="utf-8"?>
+<p:sld xmlns:a="http://schemas.openxmlformats.org/drawingml/2006/main" xmlns:r="http://schemas.openxmlformats.org/officeDocument/2006/relationships" xmlns:p="http://schemas.openxmlformats.org/presentationml/2006/main">
+  <p:cSld>
+    <p:spTree>
+      <p:nvGrpSpPr>
+        <p:cNvPr id="1" name="">
+          <a:extLst>
+            <a:ext uri="{FF2B5EF4-FFF2-40B4-BE49-F238E27FC236}">
+              <a16:creationId xmlns:a16="http://schemas.microsoft.com/office/drawing/2014/main" id="{81CBFCE1-D90B-1AB6-6CD0-793AC8E71745}"/>
+            </a:ext>
+          </a:extLst>
+        </p:cNvPr>
+        <p:cNvGrpSpPr/>
+        <p:nvPr/>
+      </p:nvGrpSpPr>
+      <p:grpSpPr>
+        <a:xfrm>
+          <a:off x="0" y="0"/>
+          <a:ext cx="0" cy="0"/>
+          <a:chOff x="0" y="0"/>
+          <a:chExt cx="0" cy="0"/>
+        </a:xfrm>
+      </p:grpSpPr>
+      <p:sp>
+        <p:nvSpPr>
+          <p:cNvPr id="3" name="TextBox 2">
+            <a:extLst>
+              <a:ext uri="{FF2B5EF4-FFF2-40B4-BE49-F238E27FC236}">
+                <a16:creationId xmlns:a16="http://schemas.microsoft.com/office/drawing/2014/main" id="{191B06A9-C41F-5824-2CA0-37B58C8E0F40}"/>
+              </a:ext>
+            </a:extLst>
+          </p:cNvPr>
+          <p:cNvSpPr txBox="1"/>
+          <p:nvPr/>
+        </p:nvSpPr>
+        <p:spPr>
+          <a:xfrm>
+            <a:off x="217714" y="255046"/>
+            <a:ext cx="11756571" cy="355354"/>
+          </a:xfrm>
+          <a:prstGeom prst="rect">
+            <a:avLst/>
+          </a:prstGeom>
+          <a:noFill/>
+        </p:spPr>
+        <p:txBody>
+          <a:bodyPr wrap="square">
+            <a:spAutoFit/>
+          </a:bodyPr>
+          <a:lstStyle/>
+          <a:p>
+            <a:pPr>
+              <a:lnSpc>
+                <a:spcPct val="150000"/>
+              </a:lnSpc>
+              <a:buNone/>
+            </a:pPr>
+            <a:r>
+              <a:rPr lang="en-US" altLang="en-US" sz="1300">
+                <a:latin typeface="Arial" panose="020B0604020202020204" pitchFamily="34" charset="0"/>
+              </a:rPr>
+              <a:t>Kateqoriya </a:t>
+            </a:r>
+            <a:r>
+              <a:rPr lang="az-Latn-AZ" altLang="en-US" sz="1300">
+                <a:latin typeface="Arial" panose="020B0604020202020204" pitchFamily="34" charset="0"/>
+              </a:rPr>
+              <a:t>üçün kontroller yaradırıq.</a:t>
+            </a:r>
+            <a:endParaRPr kumimoji="0" lang="en-US" altLang="en-US" sz="1300" b="0" i="0" u="none" strike="noStrike" cap="none" normalizeH="0" baseline="0">
+              <a:ln>
+                <a:noFill/>
+              </a:ln>
+              <a:solidFill>
+                <a:schemeClr val="tx1"/>
+              </a:solidFill>
+              <a:effectLst/>
+              <a:latin typeface="Arial" panose="020B0604020202020204" pitchFamily="34" charset="0"/>
+            </a:endParaRPr>
+          </a:p>
+        </p:txBody>
+      </p:sp>
+      <p:pic>
+        <p:nvPicPr>
+          <p:cNvPr id="4" name="Picture 3">
+            <a:extLst>
+              <a:ext uri="{FF2B5EF4-FFF2-40B4-BE49-F238E27FC236}">
+                <a16:creationId xmlns:a16="http://schemas.microsoft.com/office/drawing/2014/main" id="{522EF6B3-28C2-31D5-084D-810854557D38}"/>
+              </a:ext>
+            </a:extLst>
+          </p:cNvPr>
+          <p:cNvPicPr>
+            <a:picLocks noChangeAspect="1"/>
+          </p:cNvPicPr>
+          <p:nvPr/>
+        </p:nvPicPr>
+        <p:blipFill>
+          <a:blip r:embed="rId2"/>
+          <a:stretch>
+            <a:fillRect/>
+          </a:stretch>
+        </p:blipFill>
+        <p:spPr>
+          <a:xfrm>
+            <a:off x="0" y="4857471"/>
+            <a:ext cx="11526859" cy="2000529"/>
+          </a:xfrm>
+          <a:prstGeom prst="rect">
+            <a:avLst/>
+          </a:prstGeom>
+        </p:spPr>
+      </p:pic>
+    </p:spTree>
+    <p:extLst>
+      <p:ext uri="{BB962C8B-B14F-4D97-AF65-F5344CB8AC3E}">
+        <p14:creationId xmlns:p14="http://schemas.microsoft.com/office/powerpoint/2010/main" val="3509157298"/>
+      </p:ext>
+    </p:extLst>
+  </p:cSld>
+  <p:clrMapOvr>
+    <a:masterClrMapping/>
+  </p:clrMapOvr>
+</p:sld>
+</file>
+
+<file path=ppt/slides/slide6.xml><?xml version="1.0" encoding="utf-8"?>
+<p:sld xmlns:a="http://schemas.openxmlformats.org/drawingml/2006/main" xmlns:r="http://schemas.openxmlformats.org/officeDocument/2006/relationships" xmlns:p="http://schemas.openxmlformats.org/presentationml/2006/main">
+  <p:cSld>
+    <p:spTree>
+      <p:nvGrpSpPr>
+        <p:cNvPr id="1" name="">
+          <a:extLst>
+            <a:ext uri="{FF2B5EF4-FFF2-40B4-BE49-F238E27FC236}">
+              <a16:creationId xmlns:a16="http://schemas.microsoft.com/office/drawing/2014/main" id="{6FA633FE-765E-9907-4F0F-5CD415979FEC}"/>
+            </a:ext>
+          </a:extLst>
+        </p:cNvPr>
+        <p:cNvGrpSpPr/>
+        <p:nvPr/>
+      </p:nvGrpSpPr>
+      <p:grpSpPr>
+        <a:xfrm>
+          <a:off x="0" y="0"/>
+          <a:ext cx="0" cy="0"/>
+          <a:chOff x="0" y="0"/>
+          <a:chExt cx="0" cy="0"/>
+        </a:xfrm>
+      </p:grpSpPr>
+      <p:sp>
+        <p:nvSpPr>
+          <p:cNvPr id="3" name="TextBox 2">
+            <a:extLst>
+              <a:ext uri="{FF2B5EF4-FFF2-40B4-BE49-F238E27FC236}">
+                <a16:creationId xmlns:a16="http://schemas.microsoft.com/office/drawing/2014/main" id="{346ADF17-90C8-7879-9324-3EF5B7D3C262}"/>
+              </a:ext>
+            </a:extLst>
+          </p:cNvPr>
+          <p:cNvSpPr txBox="1"/>
+          <p:nvPr/>
+        </p:nvSpPr>
+        <p:spPr>
+          <a:xfrm>
+            <a:off x="217714" y="255046"/>
+            <a:ext cx="11756571" cy="355354"/>
+          </a:xfrm>
+          <a:prstGeom prst="rect">
+            <a:avLst/>
+          </a:prstGeom>
+          <a:noFill/>
+        </p:spPr>
+        <p:txBody>
+          <a:bodyPr wrap="square">
+            <a:spAutoFit/>
+          </a:bodyPr>
+          <a:lstStyle/>
+          <a:p>
+            <a:pPr>
+              <a:lnSpc>
+                <a:spcPct val="150000"/>
+              </a:lnSpc>
+              <a:buNone/>
+            </a:pPr>
+            <a:r>
+              <a:rPr lang="az-Latn-AZ" altLang="en-US" sz="1300">
+                <a:latin typeface="Arial" panose="020B0604020202020204" pitchFamily="34" charset="0"/>
+              </a:rPr>
+              <a:t>Model və migration yaradırıq.</a:t>
+            </a:r>
+            <a:endParaRPr kumimoji="0" lang="en-US" altLang="en-US" sz="1300" b="0" i="0" u="none" strike="noStrike" cap="none" normalizeH="0" baseline="0">
+              <a:ln>
+                <a:noFill/>
+              </a:ln>
+              <a:solidFill>
+                <a:schemeClr val="tx1"/>
+              </a:solidFill>
+              <a:effectLst/>
+              <a:latin typeface="Arial" panose="020B0604020202020204" pitchFamily="34" charset="0"/>
+            </a:endParaRPr>
+          </a:p>
+        </p:txBody>
+      </p:sp>
+      <p:pic>
+        <p:nvPicPr>
+          <p:cNvPr id="4" name="Picture 3">
+            <a:extLst>
+              <a:ext uri="{FF2B5EF4-FFF2-40B4-BE49-F238E27FC236}">
+                <a16:creationId xmlns:a16="http://schemas.microsoft.com/office/drawing/2014/main" id="{CB079B11-9A5A-D943-4929-AE6700DE84CB}"/>
+              </a:ext>
+            </a:extLst>
+          </p:cNvPr>
+          <p:cNvPicPr>
+            <a:picLocks noChangeAspect="1"/>
+          </p:cNvPicPr>
+          <p:nvPr/>
+        </p:nvPicPr>
+        <p:blipFill>
+          <a:blip r:embed="rId2"/>
+          <a:stretch>
+            <a:fillRect/>
+          </a:stretch>
+        </p:blipFill>
+        <p:spPr>
+          <a:xfrm>
+            <a:off x="0" y="4895976"/>
+            <a:ext cx="12192000" cy="1962024"/>
+          </a:xfrm>
+          <a:prstGeom prst="rect">
+            <a:avLst/>
+          </a:prstGeom>
+        </p:spPr>
+      </p:pic>
+    </p:spTree>
+    <p:extLst>
+      <p:ext uri="{BB962C8B-B14F-4D97-AF65-F5344CB8AC3E}">
+        <p14:creationId xmlns:p14="http://schemas.microsoft.com/office/powerpoint/2010/main" val="2369275463"/>
+      </p:ext>
+    </p:extLst>
+  </p:cSld>
+  <p:clrMapOvr>
+    <a:masterClrMapping/>
+  </p:clrMapOvr>
+</p:sld>
+</file>
+
+<file path=ppt/slides/slide7.xml><?xml version="1.0" encoding="utf-8"?>
+<p:sld xmlns:a="http://schemas.openxmlformats.org/drawingml/2006/main" xmlns:r="http://schemas.openxmlformats.org/officeDocument/2006/relationships" xmlns:p="http://schemas.openxmlformats.org/presentationml/2006/main">
+  <p:cSld>
+    <p:spTree>
+      <p:nvGrpSpPr>
+        <p:cNvPr id="1" name="">
+          <a:extLst>
+            <a:ext uri="{FF2B5EF4-FFF2-40B4-BE49-F238E27FC236}">
+              <a16:creationId xmlns:a16="http://schemas.microsoft.com/office/drawing/2014/main" id="{56A2CF4A-1F78-C42A-F70B-E87FEA6577B1}"/>
+            </a:ext>
+          </a:extLst>
+        </p:cNvPr>
+        <p:cNvGrpSpPr/>
+        <p:nvPr/>
+      </p:nvGrpSpPr>
+      <p:grpSpPr>
+        <a:xfrm>
+          <a:off x="0" y="0"/>
+          <a:ext cx="0" cy="0"/>
+          <a:chOff x="0" y="0"/>
+          <a:chExt cx="0" cy="0"/>
+        </a:xfrm>
+      </p:grpSpPr>
+      <p:sp>
+        <p:nvSpPr>
+          <p:cNvPr id="3" name="TextBox 2">
+            <a:extLst>
+              <a:ext uri="{FF2B5EF4-FFF2-40B4-BE49-F238E27FC236}">
+                <a16:creationId xmlns:a16="http://schemas.microsoft.com/office/drawing/2014/main" id="{861F05CB-F366-927D-D3DD-8D41240287B9}"/>
+              </a:ext>
+            </a:extLst>
+          </p:cNvPr>
+          <p:cNvSpPr txBox="1"/>
+          <p:nvPr/>
+        </p:nvSpPr>
+        <p:spPr>
+          <a:xfrm>
+            <a:off x="217713" y="49279"/>
+            <a:ext cx="11756571" cy="355354"/>
+          </a:xfrm>
+          <a:prstGeom prst="rect">
+            <a:avLst/>
+          </a:prstGeom>
+          <a:noFill/>
+        </p:spPr>
+        <p:txBody>
+          <a:bodyPr wrap="square">
+            <a:spAutoFit/>
+          </a:bodyPr>
+          <a:lstStyle/>
+          <a:p>
+            <a:pPr>
+              <a:lnSpc>
+                <a:spcPct val="150000"/>
+              </a:lnSpc>
+              <a:buNone/>
+            </a:pPr>
+            <a:r>
+              <a:rPr lang="az-Latn-AZ" altLang="en-US" sz="1300">
+                <a:latin typeface="Arial" panose="020B0604020202020204" pitchFamily="34" charset="0"/>
+              </a:rPr>
+              <a:t>Cədvəlin sütunlarını təyin edərək onu </a:t>
+            </a:r>
+            <a:r>
+              <a:rPr lang="az-Latn-AZ" altLang="en-US" sz="1300" b="1">
+                <a:latin typeface="Arial" panose="020B0604020202020204" pitchFamily="34" charset="0"/>
+              </a:rPr>
+              <a:t>migrate</a:t>
+            </a:r>
+            <a:r>
+              <a:rPr lang="az-Latn-AZ" altLang="en-US" sz="1300">
+                <a:latin typeface="Arial" panose="020B0604020202020204" pitchFamily="34" charset="0"/>
+              </a:rPr>
+              <a:t> edirik.</a:t>
+            </a:r>
+            <a:endParaRPr kumimoji="0" lang="en-US" altLang="en-US" sz="1300" b="0" i="0" u="none" strike="noStrike" cap="none" normalizeH="0" baseline="0">
+              <a:ln>
+                <a:noFill/>
+              </a:ln>
+              <a:solidFill>
+                <a:schemeClr val="tx1"/>
+              </a:solidFill>
+              <a:effectLst/>
+              <a:latin typeface="Arial" panose="020B0604020202020204" pitchFamily="34" charset="0"/>
+            </a:endParaRPr>
+          </a:p>
+        </p:txBody>
+      </p:sp>
+      <p:pic>
+        <p:nvPicPr>
+          <p:cNvPr id="4" name="Picture 3">
+            <a:extLst>
+              <a:ext uri="{FF2B5EF4-FFF2-40B4-BE49-F238E27FC236}">
+                <a16:creationId xmlns:a16="http://schemas.microsoft.com/office/drawing/2014/main" id="{0578730B-2BB0-4F51-EA93-83BDB4DFE358}"/>
+              </a:ext>
+            </a:extLst>
+          </p:cNvPr>
+          <p:cNvPicPr>
+            <a:picLocks noChangeAspect="1"/>
+          </p:cNvPicPr>
+          <p:nvPr/>
+        </p:nvPicPr>
+        <p:blipFill>
+          <a:blip r:embed="rId2"/>
+          <a:stretch>
+            <a:fillRect/>
+          </a:stretch>
+        </p:blipFill>
+        <p:spPr>
+          <a:xfrm>
+            <a:off x="-1" y="450813"/>
+            <a:ext cx="12192000" cy="6407187"/>
+          </a:xfrm>
+          <a:prstGeom prst="rect">
+            <a:avLst/>
+          </a:prstGeom>
+        </p:spPr>
+      </p:pic>
+    </p:spTree>
+    <p:extLst>
+      <p:ext uri="{BB962C8B-B14F-4D97-AF65-F5344CB8AC3E}">
+        <p14:creationId xmlns:p14="http://schemas.microsoft.com/office/powerpoint/2010/main" val="3908417138"/>
+      </p:ext>
+    </p:extLst>
+  </p:cSld>
+  <p:clrMapOvr>
+    <a:masterClrMapping/>
+  </p:clrMapOvr>
+</p:sld>
+</file>
+
+<file path=ppt/slides/slide8.xml><?xml version="1.0" encoding="utf-8"?>
+<p:sld xmlns:a="http://schemas.openxmlformats.org/drawingml/2006/main" xmlns:r="http://schemas.openxmlformats.org/officeDocument/2006/relationships" xmlns:p="http://schemas.openxmlformats.org/presentationml/2006/main">
+  <p:cSld>
+    <p:spTree>
+      <p:nvGrpSpPr>
+        <p:cNvPr id="1" name="">
+          <a:extLst>
+            <a:ext uri="{FF2B5EF4-FFF2-40B4-BE49-F238E27FC236}">
+              <a16:creationId xmlns:a16="http://schemas.microsoft.com/office/drawing/2014/main" id="{81065E10-5C6E-C14F-ADE1-7812882357DF}"/>
+            </a:ext>
+          </a:extLst>
+        </p:cNvPr>
+        <p:cNvGrpSpPr/>
+        <p:nvPr/>
+      </p:nvGrpSpPr>
+      <p:grpSpPr>
+        <a:xfrm>
+          <a:off x="0" y="0"/>
+          <a:ext cx="0" cy="0"/>
+          <a:chOff x="0" y="0"/>
+          <a:chExt cx="0" cy="0"/>
+        </a:xfrm>
+      </p:grpSpPr>
+      <p:sp>
+        <p:nvSpPr>
+          <p:cNvPr id="3" name="TextBox 2">
+            <a:extLst>
+              <a:ext uri="{FF2B5EF4-FFF2-40B4-BE49-F238E27FC236}">
+                <a16:creationId xmlns:a16="http://schemas.microsoft.com/office/drawing/2014/main" id="{F8793D03-F4CA-654C-6792-A86D77AC0F9D}"/>
+              </a:ext>
+            </a:extLst>
+          </p:cNvPr>
+          <p:cNvSpPr txBox="1"/>
+          <p:nvPr/>
+        </p:nvSpPr>
+        <p:spPr>
+          <a:xfrm>
+            <a:off x="217713" y="64653"/>
+            <a:ext cx="11756571" cy="355354"/>
+          </a:xfrm>
+          <a:prstGeom prst="rect">
+            <a:avLst/>
+          </a:prstGeom>
+          <a:noFill/>
+        </p:spPr>
+        <p:txBody>
+          <a:bodyPr wrap="square">
+            <a:spAutoFit/>
+          </a:bodyPr>
+          <a:lstStyle/>
+          <a:p>
+            <a:pPr>
+              <a:lnSpc>
+                <a:spcPct val="150000"/>
+              </a:lnSpc>
+              <a:buNone/>
+            </a:pPr>
+            <a:r>
+              <a:rPr lang="en-US" altLang="en-US" sz="1300">
+                <a:latin typeface="Arial" panose="020B0604020202020204" pitchFamily="34" charset="0"/>
+              </a:rPr>
+              <a:t>`</a:t>
+            </a:r>
+            <a:r>
+              <a:rPr lang="en-US" altLang="en-US" sz="1300" b="1">
+                <a:latin typeface="Arial" panose="020B0604020202020204" pitchFamily="34" charset="0"/>
+              </a:rPr>
+              <a:t>routes\admin.php</a:t>
+            </a:r>
+            <a:r>
+              <a:rPr lang="en-US" altLang="en-US" sz="1300">
+                <a:latin typeface="Arial" panose="020B0604020202020204" pitchFamily="34" charset="0"/>
+              </a:rPr>
+              <a:t>` fay</a:t>
+            </a:r>
+            <a:r>
+              <a:rPr lang="az-Latn-AZ" altLang="en-US" sz="1300">
+                <a:latin typeface="Arial" panose="020B0604020202020204" pitchFamily="34" charset="0"/>
+              </a:rPr>
+              <a:t>lına </a:t>
+            </a:r>
+            <a:r>
+              <a:rPr lang="az-Latn-AZ" altLang="en-US" sz="1300" b="1">
+                <a:latin typeface="Arial" panose="020B0604020202020204" pitchFamily="34" charset="0"/>
+              </a:rPr>
+              <a:t>category</a:t>
+            </a:r>
+            <a:r>
+              <a:rPr lang="az-Latn-AZ" altLang="en-US" sz="1300">
+                <a:latin typeface="Arial" panose="020B0604020202020204" pitchFamily="34" charset="0"/>
+              </a:rPr>
+              <a:t> route -unu əlavə edirik.</a:t>
+            </a:r>
+            <a:endParaRPr kumimoji="0" lang="en-US" altLang="en-US" sz="1300" b="0" i="0" u="none" strike="noStrike" cap="none" normalizeH="0" baseline="0">
+              <a:ln>
+                <a:noFill/>
+              </a:ln>
+              <a:solidFill>
+                <a:schemeClr val="tx1"/>
+              </a:solidFill>
+              <a:effectLst/>
+              <a:latin typeface="Arial" panose="020B0604020202020204" pitchFamily="34" charset="0"/>
+            </a:endParaRPr>
+          </a:p>
+        </p:txBody>
+      </p:sp>
+      <p:pic>
+        <p:nvPicPr>
+          <p:cNvPr id="4" name="Picture 3">
+            <a:extLst>
+              <a:ext uri="{FF2B5EF4-FFF2-40B4-BE49-F238E27FC236}">
+                <a16:creationId xmlns:a16="http://schemas.microsoft.com/office/drawing/2014/main" id="{0115BF27-DE25-FB4D-F604-EFE8B0820174}"/>
+              </a:ext>
+            </a:extLst>
+          </p:cNvPr>
+          <p:cNvPicPr>
+            <a:picLocks noChangeAspect="1"/>
+          </p:cNvPicPr>
+          <p:nvPr/>
+        </p:nvPicPr>
+        <p:blipFill>
+          <a:blip r:embed="rId2"/>
+          <a:stretch>
+            <a:fillRect/>
+          </a:stretch>
+        </p:blipFill>
+        <p:spPr>
+          <a:xfrm>
+            <a:off x="-1" y="478751"/>
+            <a:ext cx="12192000" cy="6379249"/>
+          </a:xfrm>
+          <a:prstGeom prst="rect">
+            <a:avLst/>
+          </a:prstGeom>
+        </p:spPr>
+      </p:pic>
+    </p:spTree>
+    <p:extLst>
+      <p:ext uri="{BB962C8B-B14F-4D97-AF65-F5344CB8AC3E}">
+        <p14:creationId xmlns:p14="http://schemas.microsoft.com/office/powerpoint/2010/main" val="3049306949"/>
+      </p:ext>
+    </p:extLst>
+  </p:cSld>
+  <p:clrMapOvr>
+    <a:masterClrMapping/>
+  </p:clrMapOvr>
+</p:sld>
+</file>
+
+<file path=ppt/slides/slide9.xml><?xml version="1.0" encoding="utf-8"?>
+<p:sld xmlns:a="http://schemas.openxmlformats.org/drawingml/2006/main" xmlns:r="http://schemas.openxmlformats.org/officeDocument/2006/relationships" xmlns:p="http://schemas.openxmlformats.org/presentationml/2006/main">
+  <p:cSld>
+    <p:spTree>
+      <p:nvGrpSpPr>
+        <p:cNvPr id="1" name="">
+          <a:extLst>
+            <a:ext uri="{FF2B5EF4-FFF2-40B4-BE49-F238E27FC236}">
+              <a16:creationId xmlns:a16="http://schemas.microsoft.com/office/drawing/2014/main" id="{B6385512-7CDA-8104-639A-9E6E3C845E61}"/>
+            </a:ext>
+          </a:extLst>
+        </p:cNvPr>
+        <p:cNvGrpSpPr/>
+        <p:nvPr/>
+      </p:nvGrpSpPr>
+      <p:grpSpPr>
+        <a:xfrm>
+          <a:off x="0" y="0"/>
+          <a:ext cx="0" cy="0"/>
+          <a:chOff x="0" y="0"/>
+          <a:chExt cx="0" cy="0"/>
+        </a:xfrm>
+      </p:grpSpPr>
+      <p:sp>
+        <p:nvSpPr>
+          <p:cNvPr id="3" name="TextBox 2">
+            <a:extLst>
+              <a:ext uri="{FF2B5EF4-FFF2-40B4-BE49-F238E27FC236}">
+                <a16:creationId xmlns:a16="http://schemas.microsoft.com/office/drawing/2014/main" id="{42EDFA0A-F765-FF86-6DB3-4EBF343ADE83}"/>
+              </a:ext>
+            </a:extLst>
+          </p:cNvPr>
+          <p:cNvSpPr txBox="1"/>
+          <p:nvPr/>
+        </p:nvSpPr>
+        <p:spPr>
+          <a:xfrm>
+            <a:off x="217714" y="255046"/>
+            <a:ext cx="11756571" cy="355354"/>
+          </a:xfrm>
+          <a:prstGeom prst="rect">
+            <a:avLst/>
+          </a:prstGeom>
+          <a:noFill/>
+        </p:spPr>
+        <p:txBody>
+          <a:bodyPr wrap="square">
+            <a:spAutoFit/>
+          </a:bodyPr>
+          <a:lstStyle/>
+          <a:p>
+            <a:pPr>
+              <a:lnSpc>
+                <a:spcPct val="150000"/>
+              </a:lnSpc>
+              <a:buNone/>
+            </a:pPr>
+            <a:r>
+              <a:rPr lang="en-US" altLang="en-US" sz="1300" b="1">
+                <a:latin typeface="Arial" panose="020B0604020202020204" pitchFamily="34" charset="0"/>
+              </a:rPr>
+              <a:t>Kateqoriya</a:t>
+            </a:r>
+            <a:r>
+              <a:rPr lang="en-US" altLang="en-US" sz="1300">
+                <a:latin typeface="Arial" panose="020B0604020202020204" pitchFamily="34" charset="0"/>
+              </a:rPr>
+              <a:t> </a:t>
+            </a:r>
+            <a:r>
+              <a:rPr lang="az-Latn-AZ" altLang="en-US" sz="1300">
+                <a:latin typeface="Arial" panose="020B0604020202020204" pitchFamily="34" charset="0"/>
+              </a:rPr>
+              <a:t>üçün hazır </a:t>
+            </a:r>
+            <a:r>
+              <a:rPr lang="az-Latn-AZ" altLang="en-US" sz="1300" b="1">
+                <a:latin typeface="Arial" panose="020B0604020202020204" pitchFamily="34" charset="0"/>
+              </a:rPr>
+              <a:t>datatables</a:t>
+            </a:r>
+            <a:r>
+              <a:rPr lang="az-Latn-AZ" altLang="en-US" sz="1300">
+                <a:latin typeface="Arial" panose="020B0604020202020204" pitchFamily="34" charset="0"/>
+              </a:rPr>
+              <a:t> strukturunu istifadə edə bilməmiz üçün Category adında datatable yaradırıq.</a:t>
+            </a:r>
+            <a:endParaRPr kumimoji="0" lang="en-US" altLang="en-US" sz="1300" b="0" i="0" u="none" strike="noStrike" cap="none" normalizeH="0" baseline="0">
+              <a:ln>
+                <a:noFill/>
+              </a:ln>
+              <a:solidFill>
+                <a:schemeClr val="tx1"/>
+              </a:solidFill>
+              <a:effectLst/>
+              <a:latin typeface="Arial" panose="020B0604020202020204" pitchFamily="34" charset="0"/>
+            </a:endParaRPr>
+          </a:p>
+        </p:txBody>
+      </p:sp>
+      <p:pic>
+        <p:nvPicPr>
+          <p:cNvPr id="4" name="Picture 3">
+            <a:extLst>
+              <a:ext uri="{FF2B5EF4-FFF2-40B4-BE49-F238E27FC236}">
+                <a16:creationId xmlns:a16="http://schemas.microsoft.com/office/drawing/2014/main" id="{CE30138D-8D98-2207-F13F-D9194FF4EFAB}"/>
+              </a:ext>
+            </a:extLst>
+          </p:cNvPr>
+          <p:cNvPicPr>
+            <a:picLocks noChangeAspect="1"/>
+          </p:cNvPicPr>
+          <p:nvPr/>
+        </p:nvPicPr>
+        <p:blipFill>
+          <a:blip r:embed="rId2"/>
+          <a:stretch>
+            <a:fillRect/>
+          </a:stretch>
+        </p:blipFill>
+        <p:spPr>
+          <a:xfrm>
+            <a:off x="0" y="5165813"/>
+            <a:ext cx="12192000" cy="1692187"/>
+          </a:xfrm>
+          <a:prstGeom prst="rect">
+            <a:avLst/>
+          </a:prstGeom>
+        </p:spPr>
+      </p:pic>
+    </p:spTree>
+    <p:extLst>
+      <p:ext uri="{BB962C8B-B14F-4D97-AF65-F5344CB8AC3E}">
+        <p14:creationId xmlns:p14="http://schemas.microsoft.com/office/powerpoint/2010/main" val="2531943041"/>
       </p:ext>
     </p:extLst>
   </p:cSld>

</xml_diff>